<commit_message>
docs: chot Tuan 3 - cap nhat CLAUDE.md v6 (Ruff/CI) va bao cao PPTX
Phat hien qua quy trinh lacco-week-closeout moi: CLAUDE.md chua phan anh Ruff/CI da hoan thanh tu buoc 3.4; PPTX bao cao tuan chua cap nhat Tuan 3.

Co-Authored-By: Claude Sonnet 5 <noreply@anthropic.com>
Claude-Session: https://claude.ai/code/session_01SKQSe62E9cQXdPELtrxjsA
</commit_message>
<xml_diff>
--- a/docs/teaching-notes/bao-cao-tuan/Bao_cao_tien_do_Tuan_LACCO.pptx
+++ b/docs/teaching-notes/bao-cao-tuan/Bao_cao_tien_do_Tuan_LACCO.pptx
@@ -4,12 +4,12 @@
   <p:sldMasterIdLst>
     <p:sldMasterId id="2147483648" r:id="rId1"/>
   </p:sldMasterIdLst>
+  <p:notesMasterIdLst>
+    <p:notesMasterId r:id="rId3"/>
+  </p:notesMasterIdLst>
   <p:sldIdLst>
     <p:sldId id="256" r:id="rId2"/>
   </p:sldIdLst>
-  <p:notesMasterIdLst>
-    <p:notesMasterId r:id="rId3"/>
-  </p:notesMasterIdLst>
   <p:sldSz cx="12192000" cy="6858000"/>
   <p:notesSz cx="6858000" cy="12192000"/>
   <p:defaultTextStyle>
@@ -104,6 +104,11 @@
       </a:defRPr>
     </a:lvl9pPr>
   </p:defaultTextStyle>
+  <p:extLst>
+    <p:ext uri="{EFAFB233-063F-42B5-8137-9DF3F51BA10A}">
+      <p15:sldGuideLst xmlns:p15="http://schemas.microsoft.com/office/powerpoint/2012/main"/>
+    </p:ext>
+  </p:extLst>
 </p:presentation>
 </file>
 
@@ -129,234 +134,10 @@
           <a:chExt cx="0" cy="0"/>
         </a:xfrm>
       </p:grpSpPr>
-      <p:sp>
-        <p:nvSpPr>
-          <p:cNvPr id="2" name="Header Placeholder 1"/>
-          <p:cNvSpPr>
-            <a:spLocks noGrp="1"/>
-          </p:cNvSpPr>
-          <p:nvPr>
-            <p:ph type="hdr" sz="quarter"/>
-          </p:nvPr>
-        </p:nvSpPr>
-        <p:spPr>
-          <a:xfrm>
-            <a:off x="0" y="0"/>
-            <a:ext cx="2971800" cy="458788"/>
-          </a:xfrm>
-          <a:prstGeom prst="rect">
-            <a:avLst/>
-          </a:prstGeom>
-        </p:spPr>
-        <p:txBody>
-          <a:bodyPr vert="horz" lIns="91440" tIns="45720" rIns="91440" bIns="45720" rtlCol="0"/>
-          <a:lstStyle>
-            <a:lvl1pPr algn="l">
-              <a:defRPr sz="1200"/>
-            </a:lvl1pPr>
-          </a:lstStyle>
-          <a:p>
-            <a:endParaRPr lang="en-US"/>
-          </a:p>
-        </p:txBody>
-      </p:sp>
-      <p:sp>
-        <p:nvSpPr>
-          <p:cNvPr id="3" name="Date Placeholder 2"/>
-          <p:cNvSpPr>
-            <a:spLocks noGrp="1"/>
-          </p:cNvSpPr>
-          <p:nvPr>
-            <p:ph type="dt" idx="1"/>
-          </p:nvPr>
-        </p:nvSpPr>
-        <p:spPr>
-          <a:xfrm>
-            <a:off x="3884613" y="0"/>
-            <a:ext cx="2971800" cy="458788"/>
-          </a:xfrm>
-          <a:prstGeom prst="rect">
-            <a:avLst/>
-          </a:prstGeom>
-        </p:spPr>
-        <p:txBody>
-          <a:bodyPr vert="horz" lIns="91440" tIns="45720" rIns="91440" bIns="45720" rtlCol="0"/>
-          <a:lstStyle>
-            <a:lvl1pPr algn="r">
-              <a:defRPr sz="1200"/>
-            </a:lvl1pPr>
-          </a:lstStyle>
-          <a:p>
-            <a:fld id="{5282F153-3F37-0F45-9E97-73ACFA13230C}" type="datetimeFigureOut">
-              <a:rPr lang="en-US"/>
-              <a:t>7/23/19</a:t>
-            </a:fld>
-            <a:endParaRPr lang="en-US"/>
-          </a:p>
-        </p:txBody>
-      </p:sp>
-      <p:sp>
-        <p:nvSpPr>
-          <p:cNvPr id="4" name="Slide Image Placeholder 3"/>
-          <p:cNvSpPr>
-            <a:spLocks noGrp="1" noRot="1" noChangeAspect="1"/>
-          </p:cNvSpPr>
-          <p:nvPr>
-            <p:ph type="sldImg" idx="2"/>
-          </p:nvPr>
-        </p:nvSpPr>
-        <p:spPr>
-          <a:xfrm>
-            <a:off x="685800" y="1143000"/>
-            <a:ext cx="5486400" cy="3086100"/>
-          </a:xfrm>
-          <a:prstGeom prst="rect">
-            <a:avLst/>
-          </a:prstGeom>
-          <a:noFill/>
-          <a:ln w="12700">
-            <a:solidFill>
-              <a:prstClr val="black"/>
-            </a:solidFill>
-          </a:ln>
-        </p:spPr>
-        <p:txBody>
-          <a:bodyPr vert="horz" lIns="91440" tIns="45720" rIns="91440" bIns="45720" rtlCol="0" anchor="ctr"/>
-          <a:lstStyle/>
-          <a:p>
-            <a:endParaRPr lang="en-US"/>
-          </a:p>
-        </p:txBody>
-      </p:sp>
-      <p:sp>
-        <p:nvSpPr>
-          <p:cNvPr id="5" name="Notes Placeholder 4"/>
-          <p:cNvSpPr>
-            <a:spLocks noGrp="1"/>
-          </p:cNvSpPr>
-          <p:nvPr>
-            <p:ph type="body" sz="quarter" idx="3"/>
-          </p:nvPr>
-        </p:nvSpPr>
-        <p:spPr>
-          <a:xfrm>
-            <a:off x="685800" y="4400550"/>
-            <a:ext cx="5486400" cy="3600450"/>
-          </a:xfrm>
-          <a:prstGeom prst="rect">
-            <a:avLst/>
-          </a:prstGeom>
-        </p:spPr>
-        <p:txBody>
-          <a:bodyPr vert="horz" lIns="91440" tIns="45720" rIns="91440" bIns="45720" rtlCol="0"/>
-          <a:lstStyle/>
-          <a:p>
-            <a:pPr lvl="0"/>
-            <a:r>
-              <a:rPr lang="en-US"/>
-              <a:t>Click to edit Master text styles</a:t>
-            </a:r>
-          </a:p>
-          <a:p>
-            <a:pPr lvl="1"/>
-            <a:r>
-              <a:rPr lang="en-US"/>
-              <a:t>Second level</a:t>
-            </a:r>
-          </a:p>
-          <a:p>
-            <a:pPr lvl="2"/>
-            <a:r>
-              <a:rPr lang="en-US"/>
-              <a:t>Third level</a:t>
-            </a:r>
-          </a:p>
-          <a:p>
-            <a:pPr lvl="3"/>
-            <a:r>
-              <a:rPr lang="en-US"/>
-              <a:t>Fourth level</a:t>
-            </a:r>
-          </a:p>
-          <a:p>
-            <a:pPr lvl="4"/>
-            <a:r>
-              <a:rPr lang="en-US"/>
-              <a:t>Fifth level</a:t>
-            </a:r>
-          </a:p>
-        </p:txBody>
-      </p:sp>
-      <p:sp>
-        <p:nvSpPr>
-          <p:cNvPr id="6" name="Footer Placeholder 5"/>
-          <p:cNvSpPr>
-            <a:spLocks noGrp="1"/>
-          </p:cNvSpPr>
-          <p:nvPr>
-            <p:ph type="ftr" sz="quarter" idx="4"/>
-          </p:nvPr>
-        </p:nvSpPr>
-        <p:spPr>
-          <a:xfrm>
-            <a:off x="0" y="8685213"/>
-            <a:ext cx="2971800" cy="458787"/>
-          </a:xfrm>
-          <a:prstGeom prst="rect">
-            <a:avLst/>
-          </a:prstGeom>
-        </p:spPr>
-        <p:txBody>
-          <a:bodyPr vert="horz" lIns="91440" tIns="45720" rIns="91440" bIns="45720" rtlCol="0" anchor="b"/>
-          <a:lstStyle>
-            <a:lvl1pPr algn="l">
-              <a:defRPr sz="1200"/>
-            </a:lvl1pPr>
-          </a:lstStyle>
-          <a:p>
-            <a:endParaRPr lang="en-US"/>
-          </a:p>
-        </p:txBody>
-      </p:sp>
-      <p:sp>
-        <p:nvSpPr>
-          <p:cNvPr id="7" name="Slide Number Placeholder 6"/>
-          <p:cNvSpPr>
-            <a:spLocks noGrp="1"/>
-          </p:cNvSpPr>
-          <p:nvPr>
-            <p:ph type="sldNum" sz="quarter" idx="5"/>
-          </p:nvPr>
-        </p:nvSpPr>
-        <p:spPr>
-          <a:xfrm>
-            <a:off x="3884613" y="8685213"/>
-            <a:ext cx="2971800" cy="458787"/>
-          </a:xfrm>
-          <a:prstGeom prst="rect">
-            <a:avLst/>
-          </a:prstGeom>
-        </p:spPr>
-        <p:txBody>
-          <a:bodyPr vert="horz" lIns="91440" tIns="45720" rIns="91440" bIns="45720" rtlCol="0" anchor="b"/>
-          <a:lstStyle>
-            <a:lvl1pPr algn="r">
-              <a:defRPr sz="1200"/>
-            </a:lvl1pPr>
-          </a:lstStyle>
-          <a:p>
-            <a:fld id="{CE5E9CC1-C706-0F49-92D6-E571CC5EEA8F}" type="slidenum">
-              <a:rPr lang="en-US"/>
-              <a:t>‹#›</a:t>
-            </a:fld>
-            <a:endParaRPr lang="en-US"/>
-          </a:p>
-        </p:txBody>
-      </p:sp>
     </p:spTree>
     <p:extLst>
       <p:ext uri="{BB962C8B-B14F-4D97-AF65-F5344CB8AC3E}">
-        <p14:creationId xmlns:p14="http://schemas.microsoft.com/office/powerpoint/2010/main" val="1024086991"/>
+        <p14:creationId xmlns:p14="http://schemas.microsoft.com/office/powerpoint/2010/main" val="3638853363"/>
       </p:ext>
     </p:extLst>
   </p:cSld>
@@ -500,10 +281,6 @@
           <a:bodyPr/>
           <a:lstStyle/>
           <a:p>
-            <a:r>
-              <a:rPr lang="en-US" dirty="0"/>
-              <a:t/>
-            </a:r>
             <a:endParaRPr lang="en-US" dirty="0"/>
           </a:p>
         </p:txBody>
@@ -577,6 +354,11 @@
 <file path=ppt/slideMasters/slideMaster1.xml><?xml version="1.0" encoding="utf-8"?>
 <p:sldMaster xmlns:a="http://schemas.openxmlformats.org/drawingml/2006/main" xmlns:r="http://schemas.openxmlformats.org/officeDocument/2006/relationships" xmlns:p="http://schemas.openxmlformats.org/presentationml/2006/main">
   <p:cSld>
+    <p:bg>
+      <p:bgRef idx="1001">
+        <a:schemeClr val="bg1"/>
+      </p:bgRef>
+    </p:bg>
     <p:spTree>
       <p:nvGrpSpPr>
         <p:cNvPr id="1" name=""/>
@@ -859,6 +641,7 @@
         <a:solidFill>
           <a:srgbClr val="FFFFFF"/>
         </a:solidFill>
+        <a:effectLst/>
       </p:bgPr>
     </p:bg>
     <p:spTree>
@@ -894,6 +677,13 @@
           </a:solidFill>
           <a:ln/>
         </p:spPr>
+        <p:txBody>
+          <a:bodyPr/>
+          <a:lstStyle/>
+          <a:p>
+            <a:endParaRPr lang="en-US"/>
+          </a:p>
+        </p:txBody>
       </p:sp>
       <p:sp>
         <p:nvSpPr>
@@ -916,7 +706,7 @@
           <a:bodyPr wrap="square" lIns="0" tIns="0" rIns="0" bIns="0" rtlCol="0" anchor="ctr"/>
           <a:lstStyle/>
           <a:p>
-            <a:pPr algn="l" indent="0" marL="0">
+            <a:pPr marL="0" indent="0" algn="l">
               <a:buNone/>
             </a:pPr>
             <a:r>
@@ -955,7 +745,7 @@
           <a:bodyPr wrap="square" lIns="0" tIns="0" rIns="0" bIns="0" rtlCol="0" anchor="ctr"/>
           <a:lstStyle/>
           <a:p>
-            <a:pPr algn="l" indent="0" marL="0">
+            <a:pPr marL="0" indent="0" algn="l">
               <a:buNone/>
             </a:pPr>
             <a:r>
@@ -967,7 +757,7 @@
                 <a:ea typeface="Arial" pitchFamily="34" charset="-122"/>
                 <a:cs typeface="Arial" pitchFamily="34" charset="-120"/>
               </a:rPr>
-              <a:t>Giai đoạn 1 (WebApp MVP · 8 tuần)  ·  Cập nhật Tuần 2 — 22/08/2026</a:t>
+              <a:t>Giai đoạn 1 (WebApp MVP · 8 tuần)  ·  Cập nhật Tuần 3 — 03/09/2026</a:t>
             </a:r>
             <a:endParaRPr lang="en-US" sz="1200" dirty="0"/>
           </a:p>
@@ -994,6 +784,13 @@
           </a:solidFill>
           <a:ln/>
         </p:spPr>
+        <p:txBody>
+          <a:bodyPr/>
+          <a:lstStyle/>
+          <a:p>
+            <a:endParaRPr lang="en-US"/>
+          </a:p>
+        </p:txBody>
       </p:sp>
       <p:sp>
         <p:nvSpPr>
@@ -1016,7 +813,7 @@
           <a:bodyPr wrap="square" lIns="0" tIns="0" rIns="0" bIns="0" rtlCol="0" anchor="ctr"/>
           <a:lstStyle/>
           <a:p>
-            <a:pPr algn="ctr" indent="0" marL="0">
+            <a:pPr marL="0" indent="0" algn="ctr">
               <a:buNone/>
             </a:pPr>
             <a:r>
@@ -1028,7 +825,7 @@
                 <a:ea typeface="Arial" pitchFamily="34" charset="-122"/>
                 <a:cs typeface="Arial" pitchFamily="34" charset="-120"/>
               </a:rPr>
-              <a:t>31,6%</a:t>
+              <a:t>44,7%</a:t>
             </a:r>
             <a:endParaRPr lang="en-US" sz="2700" dirty="0"/>
           </a:p>
@@ -1055,7 +852,7 @@
           <a:bodyPr wrap="square" lIns="0" tIns="0" rIns="0" bIns="0" rtlCol="0" anchor="t"/>
           <a:lstStyle/>
           <a:p>
-            <a:pPr algn="ctr" indent="0" marL="0">
+            <a:pPr marL="0" indent="0" algn="ctr">
               <a:buNone/>
             </a:pPr>
             <a:r>
@@ -1067,7 +864,7 @@
                 <a:ea typeface="Arial" pitchFamily="34" charset="-122"/>
                 <a:cs typeface="Arial" pitchFamily="34" charset="-120"/>
               </a:rPr>
-              <a:t>Toàn dự án · 12/38 bước</a:t>
+              <a:t>Toàn dự án · 17/38 bước</a:t>
             </a:r>
             <a:endParaRPr lang="en-US" sz="900" dirty="0"/>
           </a:p>
@@ -1094,6 +891,13 @@
           </a:solidFill>
           <a:ln/>
         </p:spPr>
+        <p:txBody>
+          <a:bodyPr/>
+          <a:lstStyle/>
+          <a:p>
+            <a:endParaRPr lang="en-US"/>
+          </a:p>
+        </p:txBody>
       </p:sp>
       <p:sp>
         <p:nvSpPr>
@@ -1116,7 +920,7 @@
           <a:bodyPr wrap="square" lIns="0" tIns="0" rIns="0" bIns="0" rtlCol="0" anchor="ctr"/>
           <a:lstStyle/>
           <a:p>
-            <a:pPr algn="ctr" indent="0" marL="0">
+            <a:pPr marL="0" indent="0" algn="ctr">
               <a:buNone/>
             </a:pPr>
             <a:r>
@@ -1155,7 +959,7 @@
           <a:bodyPr wrap="square" lIns="0" tIns="0" rIns="0" bIns="0" rtlCol="0" anchor="t"/>
           <a:lstStyle/>
           <a:p>
-            <a:pPr algn="ctr" indent="0" marL="0">
+            <a:pPr marL="0" indent="0" algn="ctr">
               <a:buNone/>
             </a:pPr>
             <a:r>
@@ -1167,7 +971,7 @@
                 <a:ea typeface="Arial" pitchFamily="34" charset="-122"/>
                 <a:cs typeface="Arial" pitchFamily="34" charset="-120"/>
               </a:rPr>
-              <a:t>Tuần 2 · 5/5 bước</a:t>
+              <a:t>Tuần 3 · 5/5 bước</a:t>
             </a:r>
             <a:endParaRPr lang="en-US" sz="900" dirty="0"/>
           </a:p>
@@ -1194,7 +998,7 @@
           <a:bodyPr wrap="square" lIns="0" tIns="0" rIns="0" bIns="0" rtlCol="0" anchor="ctr"/>
           <a:lstStyle/>
           <a:p>
-            <a:pPr indent="0" marL="0">
+            <a:pPr marL="0" indent="0">
               <a:buNone/>
             </a:pPr>
             <a:r>
@@ -1234,6 +1038,13 @@
             <a:prstDash val="solid"/>
           </a:ln>
         </p:spPr>
+        <p:txBody>
+          <a:bodyPr/>
+          <a:lstStyle/>
+          <a:p>
+            <a:endParaRPr lang="en-US"/>
+          </a:p>
+        </p:txBody>
       </p:sp>
       <p:sp>
         <p:nvSpPr>
@@ -1259,6 +1070,13 @@
             <a:prstDash val="solid"/>
           </a:ln>
         </p:spPr>
+        <p:txBody>
+          <a:bodyPr/>
+          <a:lstStyle/>
+          <a:p>
+            <a:endParaRPr lang="en-US"/>
+          </a:p>
+        </p:txBody>
       </p:sp>
       <p:sp>
         <p:nvSpPr>
@@ -1281,7 +1099,7 @@
           <a:bodyPr wrap="square" lIns="0" tIns="0" rIns="0" bIns="0" rtlCol="0" anchor="ctr"/>
           <a:lstStyle/>
           <a:p>
-            <a:pPr algn="ctr" indent="0" marL="0">
+            <a:pPr marL="0" indent="0" algn="ctr">
               <a:buNone/>
             </a:pPr>
             <a:r>
@@ -1320,7 +1138,7 @@
           <a:bodyPr wrap="square" lIns="0" tIns="0" rIns="0" bIns="0" rtlCol="0" anchor="b"/>
           <a:lstStyle/>
           <a:p>
-            <a:pPr algn="ctr" indent="0" marL="0">
+            <a:pPr marL="0" indent="0" algn="ctr">
               <a:buNone/>
             </a:pPr>
             <a:r>
@@ -1359,7 +1177,7 @@
           <a:bodyPr wrap="square" lIns="0" tIns="0" rIns="0" bIns="0" rtlCol="0" anchor="t"/>
           <a:lstStyle/>
           <a:p>
-            <a:pPr algn="ctr" indent="0" marL="0">
+            <a:pPr marL="0" indent="0" algn="ctr">
               <a:buNone/>
             </a:pPr>
             <a:r>
@@ -1376,7 +1194,7 @@
             <a:endParaRPr lang="en-US" sz="900" dirty="0"/>
           </a:p>
           <a:p>
-            <a:pPr algn="ctr" indent="0" marL="0">
+            <a:pPr marL="0" indent="0" algn="ctr">
               <a:buNone/>
             </a:pPr>
             <a:r>
@@ -1415,6 +1233,13 @@
           </a:solidFill>
           <a:ln/>
         </p:spPr>
+        <p:txBody>
+          <a:bodyPr/>
+          <a:lstStyle/>
+          <a:p>
+            <a:endParaRPr lang="en-US"/>
+          </a:p>
+        </p:txBody>
       </p:sp>
       <p:sp>
         <p:nvSpPr>
@@ -1437,6 +1262,13 @@
           </a:solidFill>
           <a:ln/>
         </p:spPr>
+        <p:txBody>
+          <a:bodyPr/>
+          <a:lstStyle/>
+          <a:p>
+            <a:endParaRPr lang="en-US"/>
+          </a:p>
+        </p:txBody>
       </p:sp>
       <p:sp>
         <p:nvSpPr>
@@ -1459,7 +1291,7 @@
           <a:bodyPr wrap="square" lIns="0" tIns="0" rIns="0" bIns="0" rtlCol="0" anchor="ctr"/>
           <a:lstStyle/>
           <a:p>
-            <a:pPr algn="ctr" indent="0" marL="0">
+            <a:pPr marL="0" indent="0" algn="ctr">
               <a:buNone/>
             </a:pPr>
             <a:r>
@@ -1498,7 +1330,7 @@
           <a:bodyPr wrap="square" lIns="0" tIns="0" rIns="0" bIns="0" rtlCol="0" anchor="ctr"/>
           <a:lstStyle/>
           <a:p>
-            <a:pPr algn="ctr" indent="0" marL="0">
+            <a:pPr marL="0" indent="0" algn="ctr">
               <a:buNone/>
             </a:pPr>
             <a:r>
@@ -1531,7 +1363,9 @@
             <a:avLst/>
           </a:prstGeom>
           <a:solidFill>
-            <a:srgbClr val="FFFFFF"/>
+            <a:schemeClr val="tx2">
+              <a:lumMod val="75000"/>
+            </a:schemeClr>
           </a:solidFill>
           <a:ln w="19050">
             <a:solidFill>
@@ -1540,6 +1374,17 @@
             <a:prstDash val="solid"/>
           </a:ln>
         </p:spPr>
+        <p:txBody>
+          <a:bodyPr/>
+          <a:lstStyle/>
+          <a:p>
+            <a:endParaRPr lang="en-US">
+              <a:solidFill>
+                <a:schemeClr val="bg1"/>
+              </a:solidFill>
+            </a:endParaRPr>
+          </a:p>
+        </p:txBody>
       </p:sp>
       <p:sp>
         <p:nvSpPr>
@@ -1562,13 +1407,13 @@
           <a:bodyPr wrap="square" lIns="0" tIns="0" rIns="0" bIns="0" rtlCol="0" anchor="ctr"/>
           <a:lstStyle/>
           <a:p>
-            <a:pPr algn="ctr" indent="0" marL="0">
+            <a:pPr marL="0" indent="0" algn="ctr">
               <a:buNone/>
             </a:pPr>
             <a:r>
               <a:rPr lang="en-US" sz="1600" b="1" dirty="0">
                 <a:solidFill>
-                  <a:srgbClr val="6B7684"/>
+                  <a:schemeClr val="bg1"/>
                 </a:solidFill>
                 <a:latin typeface="Arial" pitchFamily="34" charset="0"/>
                 <a:ea typeface="Arial" pitchFamily="34" charset="-122"/>
@@ -1576,7 +1421,11 @@
               </a:rPr>
               <a:t>2</a:t>
             </a:r>
-            <a:endParaRPr lang="en-US" sz="1600" dirty="0"/>
+            <a:endParaRPr lang="en-US" sz="1600" dirty="0">
+              <a:solidFill>
+                <a:schemeClr val="bg1"/>
+              </a:solidFill>
+            </a:endParaRPr>
           </a:p>
         </p:txBody>
       </p:sp>
@@ -1601,7 +1450,7 @@
           <a:bodyPr wrap="square" lIns="0" tIns="0" rIns="0" bIns="0" rtlCol="0" anchor="b"/>
           <a:lstStyle/>
           <a:p>
-            <a:pPr algn="ctr" indent="0" marL="0">
+            <a:pPr marL="0" indent="0" algn="ctr">
               <a:buNone/>
             </a:pPr>
             <a:r>
@@ -1640,7 +1489,7 @@
           <a:bodyPr wrap="square" lIns="0" tIns="0" rIns="0" bIns="0" rtlCol="0" anchor="t"/>
           <a:lstStyle/>
           <a:p>
-            <a:pPr algn="ctr" indent="0" marL="0">
+            <a:pPr marL="0" indent="0" algn="ctr">
               <a:buNone/>
             </a:pPr>
             <a:r>
@@ -1657,7 +1506,7 @@
             <a:endParaRPr lang="en-US" sz="900" dirty="0"/>
           </a:p>
           <a:p>
-            <a:pPr algn="ctr" indent="0" marL="0">
+            <a:pPr marL="0" indent="0" algn="ctr">
               <a:buNone/>
             </a:pPr>
             <a:r>
@@ -1699,6 +1548,13 @@
             <a:prstDash val="solid"/>
           </a:ln>
         </p:spPr>
+        <p:txBody>
+          <a:bodyPr/>
+          <a:lstStyle/>
+          <a:p>
+            <a:endParaRPr lang="en-US"/>
+          </a:p>
+        </p:txBody>
       </p:sp>
       <p:sp>
         <p:nvSpPr>
@@ -1721,7 +1577,7 @@
           <a:bodyPr wrap="square" lIns="0" tIns="0" rIns="0" bIns="0" rtlCol="0" anchor="ctr"/>
           <a:lstStyle/>
           <a:p>
-            <a:pPr algn="ctr" indent="0" marL="0">
+            <a:pPr marL="0" indent="0" algn="ctr">
               <a:buNone/>
             </a:pPr>
             <a:r>
@@ -1760,7 +1616,7 @@
           <a:bodyPr wrap="square" lIns="0" tIns="0" rIns="0" bIns="0" rtlCol="0" anchor="b"/>
           <a:lstStyle/>
           <a:p>
-            <a:pPr algn="ctr" indent="0" marL="0">
+            <a:pPr marL="0" indent="0" algn="ctr">
               <a:buNone/>
             </a:pPr>
             <a:r>
@@ -1799,7 +1655,7 @@
           <a:bodyPr wrap="square" lIns="0" tIns="0" rIns="0" bIns="0" rtlCol="0" anchor="t"/>
           <a:lstStyle/>
           <a:p>
-            <a:pPr algn="ctr" indent="0" marL="0">
+            <a:pPr marL="0" indent="0" algn="ctr">
               <a:buNone/>
             </a:pPr>
             <a:r>
@@ -1816,7 +1672,7 @@
             <a:endParaRPr lang="en-US" sz="900" dirty="0"/>
           </a:p>
           <a:p>
-            <a:pPr algn="ctr" indent="0" marL="0">
+            <a:pPr marL="0" indent="0" algn="ctr">
               <a:buNone/>
             </a:pPr>
             <a:r>
@@ -1858,6 +1714,13 @@
             <a:prstDash val="solid"/>
           </a:ln>
         </p:spPr>
+        <p:txBody>
+          <a:bodyPr/>
+          <a:lstStyle/>
+          <a:p>
+            <a:endParaRPr lang="en-US"/>
+          </a:p>
+        </p:txBody>
       </p:sp>
       <p:sp>
         <p:nvSpPr>
@@ -1880,7 +1743,7 @@
           <a:bodyPr wrap="square" lIns="0" tIns="0" rIns="0" bIns="0" rtlCol="0" anchor="ctr"/>
           <a:lstStyle/>
           <a:p>
-            <a:pPr algn="ctr" indent="0" marL="0">
+            <a:pPr marL="0" indent="0" algn="ctr">
               <a:buNone/>
             </a:pPr>
             <a:r>
@@ -1919,7 +1782,7 @@
           <a:bodyPr wrap="square" lIns="0" tIns="0" rIns="0" bIns="0" rtlCol="0" anchor="b"/>
           <a:lstStyle/>
           <a:p>
-            <a:pPr algn="ctr" indent="0" marL="0">
+            <a:pPr marL="0" indent="0" algn="ctr">
               <a:buNone/>
             </a:pPr>
             <a:r>
@@ -1958,7 +1821,7 @@
           <a:bodyPr wrap="square" lIns="0" tIns="0" rIns="0" bIns="0" rtlCol="0" anchor="t"/>
           <a:lstStyle/>
           <a:p>
-            <a:pPr algn="ctr" indent="0" marL="0">
+            <a:pPr marL="0" indent="0" algn="ctr">
               <a:buNone/>
             </a:pPr>
             <a:r>
@@ -1975,7 +1838,7 @@
             <a:endParaRPr lang="en-US" sz="900" dirty="0"/>
           </a:p>
           <a:p>
-            <a:pPr algn="ctr" indent="0" marL="0">
+            <a:pPr marL="0" indent="0" algn="ctr">
               <a:buNone/>
             </a:pPr>
             <a:r>
@@ -2017,6 +1880,13 @@
             <a:prstDash val="solid"/>
           </a:ln>
         </p:spPr>
+        <p:txBody>
+          <a:bodyPr/>
+          <a:lstStyle/>
+          <a:p>
+            <a:endParaRPr lang="en-US"/>
+          </a:p>
+        </p:txBody>
       </p:sp>
       <p:sp>
         <p:nvSpPr>
@@ -2039,7 +1909,7 @@
           <a:bodyPr wrap="square" lIns="0" tIns="0" rIns="0" bIns="0" rtlCol="0" anchor="ctr"/>
           <a:lstStyle/>
           <a:p>
-            <a:pPr algn="ctr" indent="0" marL="0">
+            <a:pPr marL="0" indent="0" algn="ctr">
               <a:buNone/>
             </a:pPr>
             <a:r>
@@ -2078,7 +1948,7 @@
           <a:bodyPr wrap="square" lIns="0" tIns="0" rIns="0" bIns="0" rtlCol="0" anchor="b"/>
           <a:lstStyle/>
           <a:p>
-            <a:pPr algn="ctr" indent="0" marL="0">
+            <a:pPr marL="0" indent="0" algn="ctr">
               <a:buNone/>
             </a:pPr>
             <a:r>
@@ -2117,7 +1987,7 @@
           <a:bodyPr wrap="square" lIns="0" tIns="0" rIns="0" bIns="0" rtlCol="0" anchor="t"/>
           <a:lstStyle/>
           <a:p>
-            <a:pPr algn="ctr" indent="0" marL="0">
+            <a:pPr marL="0" indent="0" algn="ctr">
               <a:buNone/>
             </a:pPr>
             <a:r>
@@ -2134,7 +2004,7 @@
             <a:endParaRPr lang="en-US" sz="900" dirty="0"/>
           </a:p>
           <a:p>
-            <a:pPr algn="ctr" indent="0" marL="0">
+            <a:pPr marL="0" indent="0" algn="ctr">
               <a:buNone/>
             </a:pPr>
             <a:r>
@@ -2176,6 +2046,13 @@
             <a:prstDash val="solid"/>
           </a:ln>
         </p:spPr>
+        <p:txBody>
+          <a:bodyPr/>
+          <a:lstStyle/>
+          <a:p>
+            <a:endParaRPr lang="en-US"/>
+          </a:p>
+        </p:txBody>
       </p:sp>
       <p:sp>
         <p:nvSpPr>
@@ -2198,7 +2075,7 @@
           <a:bodyPr wrap="square" lIns="0" tIns="0" rIns="0" bIns="0" rtlCol="0" anchor="ctr"/>
           <a:lstStyle/>
           <a:p>
-            <a:pPr algn="ctr" indent="0" marL="0">
+            <a:pPr marL="0" indent="0" algn="ctr">
               <a:buNone/>
             </a:pPr>
             <a:r>
@@ -2237,7 +2114,7 @@
           <a:bodyPr wrap="square" lIns="0" tIns="0" rIns="0" bIns="0" rtlCol="0" anchor="b"/>
           <a:lstStyle/>
           <a:p>
-            <a:pPr algn="ctr" indent="0" marL="0">
+            <a:pPr marL="0" indent="0" algn="ctr">
               <a:buNone/>
             </a:pPr>
             <a:r>
@@ -2276,7 +2153,7 @@
           <a:bodyPr wrap="square" lIns="0" tIns="0" rIns="0" bIns="0" rtlCol="0" anchor="t"/>
           <a:lstStyle/>
           <a:p>
-            <a:pPr algn="ctr" indent="0" marL="0">
+            <a:pPr marL="0" indent="0" algn="ctr">
               <a:buNone/>
             </a:pPr>
             <a:r>
@@ -2293,7 +2170,7 @@
             <a:endParaRPr lang="en-US" sz="900" dirty="0"/>
           </a:p>
           <a:p>
-            <a:pPr algn="ctr" indent="0" marL="0">
+            <a:pPr marL="0" indent="0" algn="ctr">
               <a:buNone/>
             </a:pPr>
             <a:r>
@@ -2335,6 +2212,13 @@
             <a:prstDash val="solid"/>
           </a:ln>
         </p:spPr>
+        <p:txBody>
+          <a:bodyPr/>
+          <a:lstStyle/>
+          <a:p>
+            <a:endParaRPr lang="en-US"/>
+          </a:p>
+        </p:txBody>
       </p:sp>
       <p:sp>
         <p:nvSpPr>
@@ -2357,7 +2241,7 @@
           <a:bodyPr wrap="square" lIns="0" tIns="0" rIns="0" bIns="0" rtlCol="0" anchor="ctr"/>
           <a:lstStyle/>
           <a:p>
-            <a:pPr algn="ctr" indent="0" marL="0">
+            <a:pPr marL="0" indent="0" algn="ctr">
               <a:buNone/>
             </a:pPr>
             <a:r>
@@ -2396,7 +2280,7 @@
           <a:bodyPr wrap="square" lIns="0" tIns="0" rIns="0" bIns="0" rtlCol="0" anchor="b"/>
           <a:lstStyle/>
           <a:p>
-            <a:pPr algn="ctr" indent="0" marL="0">
+            <a:pPr marL="0" indent="0" algn="ctr">
               <a:buNone/>
             </a:pPr>
             <a:r>
@@ -2435,7 +2319,7 @@
           <a:bodyPr wrap="square" lIns="0" tIns="0" rIns="0" bIns="0" rtlCol="0" anchor="t"/>
           <a:lstStyle/>
           <a:p>
-            <a:pPr algn="ctr" indent="0" marL="0">
+            <a:pPr marL="0" indent="0" algn="ctr">
               <a:buNone/>
             </a:pPr>
             <a:r>
@@ -2452,7 +2336,7 @@
             <a:endParaRPr lang="en-US" sz="900" dirty="0"/>
           </a:p>
           <a:p>
-            <a:pPr algn="ctr" indent="0" marL="0">
+            <a:pPr marL="0" indent="0" algn="ctr">
               <a:buNone/>
             </a:pPr>
             <a:r>
@@ -2494,6 +2378,13 @@
             <a:prstDash val="solid"/>
           </a:ln>
         </p:spPr>
+        <p:txBody>
+          <a:bodyPr/>
+          <a:lstStyle/>
+          <a:p>
+            <a:endParaRPr lang="en-US"/>
+          </a:p>
+        </p:txBody>
       </p:sp>
       <p:sp>
         <p:nvSpPr>
@@ -2516,7 +2407,7 @@
           <a:bodyPr wrap="square" lIns="0" tIns="0" rIns="0" bIns="0" rtlCol="0" anchor="ctr"/>
           <a:lstStyle/>
           <a:p>
-            <a:pPr algn="ctr" indent="0" marL="0">
+            <a:pPr marL="0" indent="0" algn="ctr">
               <a:buNone/>
             </a:pPr>
             <a:r>
@@ -2555,7 +2446,7 @@
           <a:bodyPr wrap="square" lIns="0" tIns="0" rIns="0" bIns="0" rtlCol="0" anchor="b"/>
           <a:lstStyle/>
           <a:p>
-            <a:pPr algn="ctr" indent="0" marL="0">
+            <a:pPr marL="0" indent="0" algn="ctr">
               <a:buNone/>
             </a:pPr>
             <a:r>
@@ -2594,7 +2485,7 @@
           <a:bodyPr wrap="square" lIns="0" tIns="0" rIns="0" bIns="0" rtlCol="0" anchor="t"/>
           <a:lstStyle/>
           <a:p>
-            <a:pPr algn="ctr" indent="0" marL="0">
+            <a:pPr marL="0" indent="0" algn="ctr">
               <a:buNone/>
             </a:pPr>
             <a:r>
@@ -2611,7 +2502,7 @@
             <a:endParaRPr lang="en-US" sz="900" dirty="0"/>
           </a:p>
           <a:p>
-            <a:pPr algn="ctr" indent="0" marL="0">
+            <a:pPr marL="0" indent="0" algn="ctr">
               <a:buNone/>
             </a:pPr>
             <a:r>
@@ -2650,13 +2541,20 @@
           </a:solidFill>
           <a:ln/>
           <a:effectLst>
-            <a:outerShdw sx="100000" sy="100000" kx="0" ky="0" algn="bl" rotWithShape="0" blurRad="76200" dist="25400" dir="5400000">
+            <a:outerShdw blurRad="76200" dist="25400" dir="5400000" algn="bl" rotWithShape="0">
               <a:srgbClr val="9AA5B4">
                 <a:alpha val="25000"/>
               </a:srgbClr>
             </a:outerShdw>
           </a:effectLst>
         </p:spPr>
+        <p:txBody>
+          <a:bodyPr/>
+          <a:lstStyle/>
+          <a:p>
+            <a:endParaRPr lang="en-US"/>
+          </a:p>
+        </p:txBody>
       </p:sp>
       <p:sp>
         <p:nvSpPr>
@@ -2679,7 +2577,7 @@
           <a:bodyPr wrap="square" lIns="0" tIns="0" rIns="0" bIns="0" rtlCol="0" anchor="ctr"/>
           <a:lstStyle/>
           <a:p>
-            <a:pPr indent="0" marL="0">
+            <a:pPr marL="0" indent="0">
               <a:buNone/>
             </a:pPr>
             <a:r>
@@ -2691,7 +2589,7 @@
                 <a:ea typeface="Arial" pitchFamily="34" charset="-122"/>
                 <a:cs typeface="Arial" pitchFamily="34" charset="-120"/>
               </a:rPr>
-              <a:t>TUẦN 2 — CHI TIẾT 5 BƯỚC</a:t>
+              <a:t>TUẦN 3 — CHI TIẾT 5 BƯỚC</a:t>
             </a:r>
             <a:endParaRPr lang="en-US" sz="1300" dirty="0"/>
           </a:p>
@@ -2716,6 +2614,13 @@
           </a:solidFill>
           <a:ln/>
         </p:spPr>
+        <p:txBody>
+          <a:bodyPr/>
+          <a:lstStyle/>
+          <a:p>
+            <a:endParaRPr lang="en-US"/>
+          </a:p>
+        </p:txBody>
       </p:sp>
       <p:sp>
         <p:nvSpPr>
@@ -2738,7 +2643,7 @@
           <a:bodyPr wrap="square" lIns="0" tIns="0" rIns="0" bIns="0" rtlCol="0" anchor="ctr"/>
           <a:lstStyle/>
           <a:p>
-            <a:pPr algn="ctr" indent="0" marL="0">
+            <a:pPr marL="0" indent="0" algn="ctr">
               <a:buNone/>
             </a:pPr>
             <a:r>
@@ -2777,7 +2682,7 @@
           <a:bodyPr wrap="square" lIns="0" tIns="0" rIns="0" bIns="0" rtlCol="0" anchor="ctr"/>
           <a:lstStyle/>
           <a:p>
-            <a:pPr indent="0" marL="0">
+            <a:pPr marL="0" indent="0">
               <a:buNone/>
             </a:pPr>
             <a:r>
@@ -2789,21 +2694,7 @@
                 <a:ea typeface="Arial" pitchFamily="34" charset="-122"/>
                 <a:cs typeface="Arial" pitchFamily="34" charset="-120"/>
               </a:rPr>
-              <a:t>2.1  Thiết kế ERD &amp; giao db-schema-agent</a:t>
-            </a:r>
-            <a:pPr indent="0" marL="0">
-              <a:buNone/>
-            </a:pPr>
-            <a:r>
-              <a:rPr lang="en-US" sz="1100" dirty="0">
-                <a:solidFill>
-                  <a:srgbClr val="343B45"/>
-                </a:solidFill>
-                <a:latin typeface="Arial" pitchFamily="34" charset="0"/>
-                <a:ea typeface="Arial" pitchFamily="34" charset="-122"/>
-                <a:cs typeface="Arial" pitchFamily="34" charset="-120"/>
-              </a:rPr>
-              <a:t/>
+              <a:t>3.1  Xây Auth &amp; RBAC (bcrypt, streamlit-authenticator)</a:t>
             </a:r>
             <a:endParaRPr lang="en-US" sz="1100" dirty="0"/>
           </a:p>
@@ -2828,6 +2719,13 @@
           </a:solidFill>
           <a:ln/>
         </p:spPr>
+        <p:txBody>
+          <a:bodyPr/>
+          <a:lstStyle/>
+          <a:p>
+            <a:endParaRPr lang="en-US"/>
+          </a:p>
+        </p:txBody>
       </p:sp>
       <p:sp>
         <p:nvSpPr>
@@ -2850,7 +2748,7 @@
           <a:bodyPr wrap="square" lIns="0" tIns="0" rIns="0" bIns="0" rtlCol="0" anchor="ctr"/>
           <a:lstStyle/>
           <a:p>
-            <a:pPr algn="ctr" indent="0" marL="0">
+            <a:pPr marL="0" indent="0" algn="ctr">
               <a:buNone/>
             </a:pPr>
             <a:r>
@@ -2889,7 +2787,7 @@
           <a:bodyPr wrap="square" lIns="0" tIns="0" rIns="0" bIns="0" rtlCol="0" anchor="ctr"/>
           <a:lstStyle/>
           <a:p>
-            <a:pPr indent="0" marL="0">
+            <a:pPr marL="0" indent="0">
               <a:buNone/>
             </a:pPr>
             <a:r>
@@ -2901,21 +2799,7 @@
                 <a:ea typeface="Arial" pitchFamily="34" charset="-122"/>
                 <a:cs typeface="Arial" pitchFamily="34" charset="-120"/>
               </a:rPr>
-              <a:t>2.2  Sinh SQLAlchemy models</a:t>
-            </a:r>
-            <a:pPr indent="0" marL="0">
-              <a:buNone/>
-            </a:pPr>
-            <a:r>
-              <a:rPr lang="en-US" sz="1100" dirty="0">
-                <a:solidFill>
-                  <a:srgbClr val="343B45"/>
-                </a:solidFill>
-                <a:latin typeface="Arial" pitchFamily="34" charset="0"/>
-                <a:ea typeface="Arial" pitchFamily="34" charset="-122"/>
-                <a:cs typeface="Arial" pitchFamily="34" charset="-120"/>
-              </a:rPr>
-              <a:t/>
+              <a:t>3.2  Checklist bảo mật (qa-reviewer-agent)</a:t>
             </a:r>
             <a:endParaRPr lang="en-US" sz="1100" dirty="0"/>
           </a:p>
@@ -2940,6 +2824,13 @@
           </a:solidFill>
           <a:ln/>
         </p:spPr>
+        <p:txBody>
+          <a:bodyPr/>
+          <a:lstStyle/>
+          <a:p>
+            <a:endParaRPr lang="en-US"/>
+          </a:p>
+        </p:txBody>
       </p:sp>
       <p:sp>
         <p:nvSpPr>
@@ -2962,7 +2853,7 @@
           <a:bodyPr wrap="square" lIns="0" tIns="0" rIns="0" bIns="0" rtlCol="0" anchor="ctr"/>
           <a:lstStyle/>
           <a:p>
-            <a:pPr algn="ctr" indent="0" marL="0">
+            <a:pPr marL="0" indent="0" algn="ctr">
               <a:buNone/>
             </a:pPr>
             <a:r>
@@ -3001,7 +2892,7 @@
           <a:bodyPr wrap="square" lIns="0" tIns="0" rIns="0" bIns="0" rtlCol="0" anchor="ctr"/>
           <a:lstStyle/>
           <a:p>
-            <a:pPr indent="0" marL="0">
+            <a:pPr marL="0" indent="0">
               <a:buNone/>
             </a:pPr>
             <a:r>
@@ -3013,21 +2904,7 @@
                 <a:ea typeface="Arial" pitchFamily="34" charset="-122"/>
                 <a:cs typeface="Arial" pitchFamily="34" charset="-120"/>
               </a:rPr>
-              <a:t>2.3  Cài Alembic, migration đầu tiên</a:t>
-            </a:r>
-            <a:pPr indent="0" marL="0">
-              <a:buNone/>
-            </a:pPr>
-            <a:r>
-              <a:rPr lang="en-US" sz="1100" dirty="0">
-                <a:solidFill>
-                  <a:srgbClr val="343B45"/>
-                </a:solidFill>
-                <a:latin typeface="Arial" pitchFamily="34" charset="0"/>
-                <a:ea typeface="Arial" pitchFamily="34" charset="-122"/>
-                <a:cs typeface="Arial" pitchFamily="34" charset="-120"/>
-              </a:rPr>
-              <a:t/>
+              <a:t>3.3  Viết test đầu tiên (pytest, 13 test)</a:t>
             </a:r>
             <a:endParaRPr lang="en-US" sz="1100" dirty="0"/>
           </a:p>
@@ -3052,6 +2929,13 @@
           </a:solidFill>
           <a:ln/>
         </p:spPr>
+        <p:txBody>
+          <a:bodyPr/>
+          <a:lstStyle/>
+          <a:p>
+            <a:endParaRPr lang="en-US"/>
+          </a:p>
+        </p:txBody>
       </p:sp>
       <p:sp>
         <p:nvSpPr>
@@ -3074,7 +2958,7 @@
           <a:bodyPr wrap="square" lIns="0" tIns="0" rIns="0" bIns="0" rtlCol="0" anchor="ctr"/>
           <a:lstStyle/>
           <a:p>
-            <a:pPr algn="ctr" indent="0" marL="0">
+            <a:pPr marL="0" indent="0" algn="ctr">
               <a:buNone/>
             </a:pPr>
             <a:r>
@@ -3113,7 +2997,7 @@
           <a:bodyPr wrap="square" lIns="0" tIns="0" rIns="0" bIns="0" rtlCol="0" anchor="ctr"/>
           <a:lstStyle/>
           <a:p>
-            <a:pPr indent="0" marL="0">
+            <a:pPr marL="0" indent="0">
               <a:buNone/>
             </a:pPr>
             <a:r>
@@ -3125,21 +3009,7 @@
                 <a:ea typeface="Arial" pitchFamily="34" charset="-122"/>
                 <a:cs typeface="Arial" pitchFamily="34" charset="-120"/>
               </a:rPr>
-              <a:t>2.4  Pipeline import Excel/CSV (Pandera)</a:t>
-            </a:r>
-            <a:pPr indent="0" marL="0">
-              <a:buNone/>
-            </a:pPr>
-            <a:r>
-              <a:rPr lang="en-US" sz="1100" dirty="0">
-                <a:solidFill>
-                  <a:srgbClr val="343B45"/>
-                </a:solidFill>
-                <a:latin typeface="Arial" pitchFamily="34" charset="0"/>
-                <a:ea typeface="Arial" pitchFamily="34" charset="-122"/>
-                <a:cs typeface="Arial" pitchFamily="34" charset="-120"/>
-              </a:rPr>
-              <a:t/>
+              <a:t>3.4  Cấu hình CI (Ruff + GitHub Actions)</a:t>
             </a:r>
             <a:endParaRPr lang="en-US" sz="1100" dirty="0"/>
           </a:p>
@@ -3164,6 +3034,13 @@
           </a:solidFill>
           <a:ln/>
         </p:spPr>
+        <p:txBody>
+          <a:bodyPr/>
+          <a:lstStyle/>
+          <a:p>
+            <a:endParaRPr lang="en-US"/>
+          </a:p>
+        </p:txBody>
       </p:sp>
       <p:sp>
         <p:nvSpPr>
@@ -3186,7 +3063,7 @@
           <a:bodyPr wrap="square" lIns="0" tIns="0" rIns="0" bIns="0" rtlCol="0" anchor="ctr"/>
           <a:lstStyle/>
           <a:p>
-            <a:pPr algn="ctr" indent="0" marL="0">
+            <a:pPr marL="0" indent="0" algn="ctr">
               <a:buNone/>
             </a:pPr>
             <a:r>
@@ -3225,7 +3102,7 @@
           <a:bodyPr wrap="square" lIns="0" tIns="0" rIns="0" bIns="0" rtlCol="0" anchor="ctr"/>
           <a:lstStyle/>
           <a:p>
-            <a:pPr indent="0" marL="0">
+            <a:pPr marL="0" indent="0">
               <a:buNone/>
             </a:pPr>
             <a:r>
@@ -3237,21 +3114,7 @@
                 <a:ea typeface="Arial" pitchFamily="34" charset="-122"/>
                 <a:cs typeface="Arial" pitchFamily="34" charset="-120"/>
               </a:rPr>
-              <a:t>2.5  Review &amp; nhật ký Tuần 2</a:t>
-            </a:r>
-            <a:pPr indent="0" marL="0">
-              <a:buNone/>
-            </a:pPr>
-            <a:r>
-              <a:rPr lang="en-US" sz="1100" dirty="0">
-                <a:solidFill>
-                  <a:srgbClr val="343B45"/>
-                </a:solidFill>
-                <a:latin typeface="Arial" pitchFamily="34" charset="0"/>
-                <a:ea typeface="Arial" pitchFamily="34" charset="-122"/>
-                <a:cs typeface="Arial" pitchFamily="34" charset="-120"/>
-              </a:rPr>
-              <a:t/>
+              <a:t>3.5  Review &amp; nhật ký Tuần 3</a:t>
             </a:r>
             <a:endParaRPr lang="en-US" sz="1100" dirty="0"/>
           </a:p>
@@ -3278,13 +3141,20 @@
           </a:solidFill>
           <a:ln/>
           <a:effectLst>
-            <a:outerShdw sx="100000" sy="100000" kx="0" ky="0" algn="bl" rotWithShape="0" blurRad="76200" dist="25400" dir="5400000">
+            <a:outerShdw blurRad="76200" dist="25400" dir="5400000" algn="bl" rotWithShape="0">
               <a:srgbClr val="9AA5B4">
                 <a:alpha val="25000"/>
               </a:srgbClr>
             </a:outerShdw>
           </a:effectLst>
         </p:spPr>
+        <p:txBody>
+          <a:bodyPr/>
+          <a:lstStyle/>
+          <a:p>
+            <a:endParaRPr lang="en-US"/>
+          </a:p>
+        </p:txBody>
       </p:sp>
       <p:sp>
         <p:nvSpPr>
@@ -3307,7 +3177,7 @@
           <a:bodyPr wrap="square" lIns="0" tIns="0" rIns="0" bIns="0" rtlCol="0" anchor="ctr"/>
           <a:lstStyle/>
           <a:p>
-            <a:pPr indent="0" marL="0">
+            <a:pPr marL="0" indent="0">
               <a:buNone/>
             </a:pPr>
             <a:r>
@@ -3365,7 +3235,7 @@
                 <a:ea typeface="Arial" pitchFamily="34" charset="-122"/>
                 <a:cs typeface="Arial" pitchFamily="34" charset="-120"/>
               </a:rPr>
-              <a:t>Đổi mật khẩu MySQL bị lộ trong chat ở bước 2.3 (chưa xác nhận đã xử lý) — cập nhật lại .env và cấu hình MCP sau khi đổi</a:t>
+              <a:t>Bắt đầu bước 4.1 — Module báo cáo đợt 1</a:t>
             </a:r>
             <a:endParaRPr lang="en-US" sz="1100" dirty="0"/>
           </a:p>
@@ -3389,7 +3259,7 @@
                 <a:ea typeface="Arial" pitchFamily="34" charset="-122"/>
                 <a:cs typeface="Arial" pitchFamily="34" charset="-120"/>
               </a:rPr>
-              <a:t>Tạo requirements.txt trước khi Tuần 3 thêm dependency mới (streamlit-authenticator, bcrypt)</a:t>
+              <a:t>Rủi ro RBAC: 1 khách hàng có thể gắn 2 nhân viên khác nhau (Manager/User) — cần xử lý trước khi code báo cáo Khách hàng</a:t>
             </a:r>
             <a:endParaRPr lang="en-US" sz="1100" dirty="0"/>
           </a:p>
@@ -3413,7 +3283,7 @@
                 <a:ea typeface="Arial" pitchFamily="34" charset="-122"/>
                 <a:cs typeface="Arial" pitchFamily="34" charset="-120"/>
               </a:rPr>
-              <a:t>Chốt dần các mục ERD còn mở (8/10) — ưu tiên debt.aging_bucket trước khi có module báo cáo Công nợ</a:t>
+              <a:t>Tạo user MySQL least-privilege thay cho root trong .env — tồn đọng từ Tuần 1, ưu tiên tăng vì Auth/RBAC đã chạy thật</a:t>
             </a:r>
             <a:endParaRPr lang="en-US" sz="1100" dirty="0"/>
           </a:p>
@@ -3437,7 +3307,7 @@
                 <a:ea typeface="Arial" pitchFamily="34" charset="-122"/>
                 <a:cs typeface="Arial" pitchFamily="34" charset="-120"/>
               </a:rPr>
-              <a:t>Bắt đầu bước 3.1 — Xây Auth &amp; RBAC (đăng nhập, bcrypt, session, RBAC 3 cấp theo Khối/Phòng và KH A/B/C)</a:t>
+              <a:t>_DEV_FALLBACK_COOKIE_KEY hardcoded trong authentication.py — cần đổi thành raise lỗi trước khi có production thật</a:t>
             </a:r>
             <a:endParaRPr lang="en-US" sz="1100" dirty="0"/>
           </a:p>
@@ -3464,7 +3334,7 @@
           <a:bodyPr wrap="square" lIns="0" tIns="0" rIns="0" bIns="0" rtlCol="0" anchor="ctr"/>
           <a:lstStyle/>
           <a:p>
-            <a:pPr algn="l" indent="0" marL="0">
+            <a:pPr marL="0" indent="0" algn="l">
               <a:buNone/>
             </a:pPr>
             <a:r>
@@ -3479,6 +3349,74 @@
               <a:t>Nguồn dữ liệu: Lich_trinh_thuc_hien_8_tuan_LACCO.xlsx  ·  Slide cập nhật hàng tuần cho Ban Lãnh đạo  ·  Dự án Dashboard LACCO — Giai đoạn 1</a:t>
             </a:r>
             <a:endParaRPr lang="en-US" sz="900" dirty="0"/>
+          </a:p>
+        </p:txBody>
+      </p:sp>
+      <p:sp>
+        <p:nvSpPr>
+          <p:cNvPr id="3017" name="Shape 15 (Tuan3)"/>
+          <p:cNvSpPr/>
+          <p:nvPr/>
+        </p:nvSpPr>
+        <p:spPr>
+          <a:xfrm>
+            <a:off x="3371524" y="3182112"/>
+            <a:ext cx="1133856" cy="237744"/>
+          </a:xfrm>
+          <a:prstGeom prst="roundRect">
+            <a:avLst>
+              <a:gd name="adj" fmla="val 23077"/>
+            </a:avLst>
+          </a:prstGeom>
+          <a:solidFill>
+            <a:srgbClr val="2E8B57"/>
+          </a:solidFill>
+          <a:ln/>
+        </p:spPr>
+        <p:txBody>
+          <a:bodyPr/>
+          <a:lstStyle/>
+          <a:p>
+            <a:endParaRPr lang="en-US"/>
+          </a:p>
+        </p:txBody>
+      </p:sp>
+      <p:sp>
+        <p:nvSpPr>
+          <p:cNvPr id="3019" name="Text 16 (Tuan3)"/>
+          <p:cNvSpPr/>
+          <p:nvPr/>
+        </p:nvSpPr>
+        <p:spPr>
+          <a:xfrm>
+            <a:off x="3371524" y="3182112"/>
+            <a:ext cx="1133856" cy="237744"/>
+          </a:xfrm>
+          <a:prstGeom prst="rect">
+            <a:avLst/>
+          </a:prstGeom>
+          <a:noFill/>
+          <a:ln/>
+        </p:spPr>
+        <p:txBody>
+          <a:bodyPr wrap="square" lIns="0" tIns="0" rIns="0" bIns="0" rtlCol="0" anchor="ctr"/>
+          <a:lstStyle/>
+          <a:p>
+            <a:pPr marL="0" indent="0" algn="ctr">
+              <a:buNone/>
+            </a:pPr>
+            <a:r>
+              <a:rPr lang="en-US" sz="850" b="1" dirty="0">
+                <a:solidFill>
+                  <a:srgbClr val="FFFFFF"/>
+                </a:solidFill>
+                <a:latin typeface="Arial" pitchFamily="34" charset="0"/>
+                <a:ea typeface="Arial" pitchFamily="34" charset="-122"/>
+                <a:cs typeface="Arial" pitchFamily="34" charset="-120"/>
+              </a:rPr>
+              <a:t>Hoàn thành · 100%</a:t>
+            </a:r>
+            <a:endParaRPr lang="en-US" sz="850" dirty="0"/>
           </a:p>
         </p:txBody>
       </p:sp>
@@ -3783,4 +3721,319 @@
     </a:ext>
   </a:extLst>
 </a:theme>
+</file>
+
+<file path=ppt/theme/theme2.xml><?xml version="1.0" encoding="utf-8"?>
+<a:theme xmlns:a="http://schemas.openxmlformats.org/drawingml/2006/main" name="Office Theme">
+  <a:themeElements>
+    <a:clrScheme name="Office">
+      <a:dk1>
+        <a:sysClr val="windowText" lastClr="000000"/>
+      </a:dk1>
+      <a:lt1>
+        <a:sysClr val="window" lastClr="FFFFFF"/>
+      </a:lt1>
+      <a:dk2>
+        <a:srgbClr val="0E2841"/>
+      </a:dk2>
+      <a:lt2>
+        <a:srgbClr val="E8E8E8"/>
+      </a:lt2>
+      <a:accent1>
+        <a:srgbClr val="156082"/>
+      </a:accent1>
+      <a:accent2>
+        <a:srgbClr val="E97132"/>
+      </a:accent2>
+      <a:accent3>
+        <a:srgbClr val="196B24"/>
+      </a:accent3>
+      <a:accent4>
+        <a:srgbClr val="0F9ED5"/>
+      </a:accent4>
+      <a:accent5>
+        <a:srgbClr val="A02B93"/>
+      </a:accent5>
+      <a:accent6>
+        <a:srgbClr val="4EA72E"/>
+      </a:accent6>
+      <a:hlink>
+        <a:srgbClr val="467886"/>
+      </a:hlink>
+      <a:folHlink>
+        <a:srgbClr val="96607D"/>
+      </a:folHlink>
+    </a:clrScheme>
+    <a:fontScheme name="Office">
+      <a:majorFont>
+        <a:latin typeface="Aptos Display" panose="02110004020202020204"/>
+        <a:ea typeface=""/>
+        <a:cs typeface=""/>
+        <a:font script="Jpan" typeface="游ゴシック Light"/>
+        <a:font script="Hang" typeface="맑은 고딕"/>
+        <a:font script="Hans" typeface="等线 Light"/>
+        <a:font script="Hant" typeface="新細明體"/>
+        <a:font script="Arab" typeface="Times New Roman"/>
+        <a:font script="Hebr" typeface="Times New Roman"/>
+        <a:font script="Thai" typeface="Angsana New"/>
+        <a:font script="Ethi" typeface="Nyala"/>
+        <a:font script="Beng" typeface="Vrinda"/>
+        <a:font script="Gujr" typeface="Shruti"/>
+        <a:font script="Khmr" typeface="MoolBoran"/>
+        <a:font script="Knda" typeface="Tunga"/>
+        <a:font script="Guru" typeface="Raavi"/>
+        <a:font script="Cans" typeface="Euphemia"/>
+        <a:font script="Cher" typeface="Plantagenet Cherokee"/>
+        <a:font script="Yiii" typeface="Microsoft Yi Baiti"/>
+        <a:font script="Tibt" typeface="Microsoft Himalaya"/>
+        <a:font script="Thaa" typeface="MV Boli"/>
+        <a:font script="Deva" typeface="Mangal"/>
+        <a:font script="Telu" typeface="Gautami"/>
+        <a:font script="Taml" typeface="Latha"/>
+        <a:font script="Syrc" typeface="Estrangelo Edessa"/>
+        <a:font script="Orya" typeface="Kalinga"/>
+        <a:font script="Mlym" typeface="Kartika"/>
+        <a:font script="Laoo" typeface="DokChampa"/>
+        <a:font script="Sinh" typeface="Iskoola Pota"/>
+        <a:font script="Mong" typeface="Mongolian Baiti"/>
+        <a:font script="Viet" typeface="Times New Roman"/>
+        <a:font script="Uigh" typeface="Microsoft Uighur"/>
+        <a:font script="Geor" typeface="Sylfaen"/>
+        <a:font script="Armn" typeface="Arial"/>
+        <a:font script="Bugi" typeface="Leelawadee UI"/>
+        <a:font script="Bopo" typeface="Microsoft JhengHei"/>
+        <a:font script="Java" typeface="Javanese Text"/>
+        <a:font script="Lisu" typeface="Segoe UI"/>
+        <a:font script="Mymr" typeface="Myanmar Text"/>
+        <a:font script="Nkoo" typeface="Ebrima"/>
+        <a:font script="Olck" typeface="Nirmala UI"/>
+        <a:font script="Osma" typeface="Ebrima"/>
+        <a:font script="Phag" typeface="Phagspa"/>
+        <a:font script="Syrn" typeface="Estrangelo Edessa"/>
+        <a:font script="Syrj" typeface="Estrangelo Edessa"/>
+        <a:font script="Syre" typeface="Estrangelo Edessa"/>
+        <a:font script="Sora" typeface="Nirmala UI"/>
+        <a:font script="Tale" typeface="Microsoft Tai Le"/>
+        <a:font script="Talu" typeface="Microsoft New Tai Lue"/>
+        <a:font script="Tfng" typeface="Ebrima"/>
+      </a:majorFont>
+      <a:minorFont>
+        <a:latin typeface="Aptos" panose="02110004020202020204"/>
+        <a:ea typeface=""/>
+        <a:cs typeface=""/>
+        <a:font script="Jpan" typeface="游ゴシック"/>
+        <a:font script="Hang" typeface="맑은 고딕"/>
+        <a:font script="Hans" typeface="等线"/>
+        <a:font script="Hant" typeface="新細明體"/>
+        <a:font script="Arab" typeface="Arial"/>
+        <a:font script="Hebr" typeface="Arial"/>
+        <a:font script="Thai" typeface="Cordia New"/>
+        <a:font script="Ethi" typeface="Nyala"/>
+        <a:font script="Beng" typeface="Vrinda"/>
+        <a:font script="Gujr" typeface="Shruti"/>
+        <a:font script="Khmr" typeface="DaunPenh"/>
+        <a:font script="Knda" typeface="Tunga"/>
+        <a:font script="Guru" typeface="Raavi"/>
+        <a:font script="Cans" typeface="Euphemia"/>
+        <a:font script="Cher" typeface="Plantagenet Cherokee"/>
+        <a:font script="Yiii" typeface="Microsoft Yi Baiti"/>
+        <a:font script="Tibt" typeface="Microsoft Himalaya"/>
+        <a:font script="Thaa" typeface="MV Boli"/>
+        <a:font script="Deva" typeface="Mangal"/>
+        <a:font script="Telu" typeface="Gautami"/>
+        <a:font script="Taml" typeface="Latha"/>
+        <a:font script="Syrc" typeface="Estrangelo Edessa"/>
+        <a:font script="Orya" typeface="Kalinga"/>
+        <a:font script="Mlym" typeface="Kartika"/>
+        <a:font script="Laoo" typeface="DokChampa"/>
+        <a:font script="Sinh" typeface="Iskoola Pota"/>
+        <a:font script="Mong" typeface="Mongolian Baiti"/>
+        <a:font script="Viet" typeface="Arial"/>
+        <a:font script="Uigh" typeface="Microsoft Uighur"/>
+        <a:font script="Geor" typeface="Sylfaen"/>
+        <a:font script="Armn" typeface="Arial"/>
+        <a:font script="Bugi" typeface="Leelawadee UI"/>
+        <a:font script="Bopo" typeface="Microsoft JhengHei"/>
+        <a:font script="Java" typeface="Javanese Text"/>
+        <a:font script="Lisu" typeface="Segoe UI"/>
+        <a:font script="Mymr" typeface="Myanmar Text"/>
+        <a:font script="Nkoo" typeface="Ebrima"/>
+        <a:font script="Olck" typeface="Nirmala UI"/>
+        <a:font script="Osma" typeface="Ebrima"/>
+        <a:font script="Phag" typeface="Phagspa"/>
+        <a:font script="Syrn" typeface="Estrangelo Edessa"/>
+        <a:font script="Syrj" typeface="Estrangelo Edessa"/>
+        <a:font script="Syre" typeface="Estrangelo Edessa"/>
+        <a:font script="Sora" typeface="Nirmala UI"/>
+        <a:font script="Tale" typeface="Microsoft Tai Le"/>
+        <a:font script="Talu" typeface="Microsoft New Tai Lue"/>
+        <a:font script="Tfng" typeface="Ebrima"/>
+      </a:minorFont>
+    </a:fontScheme>
+    <a:fmtScheme name="Office">
+      <a:fillStyleLst>
+        <a:solidFill>
+          <a:schemeClr val="phClr"/>
+        </a:solidFill>
+        <a:gradFill rotWithShape="1">
+          <a:gsLst>
+            <a:gs pos="0">
+              <a:schemeClr val="phClr">
+                <a:lumMod val="110000"/>
+                <a:satMod val="105000"/>
+                <a:tint val="67000"/>
+              </a:schemeClr>
+            </a:gs>
+            <a:gs pos="50000">
+              <a:schemeClr val="phClr">
+                <a:lumMod val="105000"/>
+                <a:satMod val="103000"/>
+                <a:tint val="73000"/>
+              </a:schemeClr>
+            </a:gs>
+            <a:gs pos="100000">
+              <a:schemeClr val="phClr">
+                <a:lumMod val="105000"/>
+                <a:satMod val="109000"/>
+                <a:tint val="81000"/>
+              </a:schemeClr>
+            </a:gs>
+          </a:gsLst>
+          <a:lin ang="5400000" scaled="0"/>
+        </a:gradFill>
+        <a:gradFill rotWithShape="1">
+          <a:gsLst>
+            <a:gs pos="0">
+              <a:schemeClr val="phClr">
+                <a:satMod val="103000"/>
+                <a:lumMod val="102000"/>
+                <a:tint val="94000"/>
+              </a:schemeClr>
+            </a:gs>
+            <a:gs pos="50000">
+              <a:schemeClr val="phClr">
+                <a:satMod val="110000"/>
+                <a:lumMod val="100000"/>
+                <a:shade val="100000"/>
+              </a:schemeClr>
+            </a:gs>
+            <a:gs pos="100000">
+              <a:schemeClr val="phClr">
+                <a:lumMod val="99000"/>
+                <a:satMod val="120000"/>
+                <a:shade val="78000"/>
+              </a:schemeClr>
+            </a:gs>
+          </a:gsLst>
+          <a:lin ang="5400000" scaled="0"/>
+        </a:gradFill>
+      </a:fillStyleLst>
+      <a:lnStyleLst>
+        <a:ln w="12700" cap="flat" cmpd="sng" algn="ctr">
+          <a:solidFill>
+            <a:schemeClr val="phClr"/>
+          </a:solidFill>
+          <a:prstDash val="solid"/>
+          <a:miter lim="800000"/>
+        </a:ln>
+        <a:ln w="19050" cap="flat" cmpd="sng" algn="ctr">
+          <a:solidFill>
+            <a:schemeClr val="phClr"/>
+          </a:solidFill>
+          <a:prstDash val="solid"/>
+          <a:miter lim="800000"/>
+        </a:ln>
+        <a:ln w="25400" cap="flat" cmpd="sng" algn="ctr">
+          <a:solidFill>
+            <a:schemeClr val="phClr"/>
+          </a:solidFill>
+          <a:prstDash val="solid"/>
+          <a:miter lim="800000"/>
+        </a:ln>
+      </a:lnStyleLst>
+      <a:effectStyleLst>
+        <a:effectStyle>
+          <a:effectLst/>
+        </a:effectStyle>
+        <a:effectStyle>
+          <a:effectLst/>
+        </a:effectStyle>
+        <a:effectStyle>
+          <a:effectLst>
+            <a:outerShdw blurRad="57150" dist="19050" dir="5400000" algn="ctr" rotWithShape="0">
+              <a:srgbClr val="000000">
+                <a:alpha val="63000"/>
+              </a:srgbClr>
+            </a:outerShdw>
+          </a:effectLst>
+        </a:effectStyle>
+      </a:effectStyleLst>
+      <a:bgFillStyleLst>
+        <a:solidFill>
+          <a:schemeClr val="phClr"/>
+        </a:solidFill>
+        <a:solidFill>
+          <a:schemeClr val="phClr">
+            <a:tint val="95000"/>
+            <a:satMod val="170000"/>
+          </a:schemeClr>
+        </a:solidFill>
+        <a:gradFill rotWithShape="1">
+          <a:gsLst>
+            <a:gs pos="0">
+              <a:schemeClr val="phClr">
+                <a:tint val="93000"/>
+                <a:satMod val="150000"/>
+                <a:shade val="98000"/>
+                <a:lumMod val="102000"/>
+              </a:schemeClr>
+            </a:gs>
+            <a:gs pos="50000">
+              <a:schemeClr val="phClr">
+                <a:tint val="98000"/>
+                <a:satMod val="130000"/>
+                <a:shade val="90000"/>
+                <a:lumMod val="103000"/>
+              </a:schemeClr>
+            </a:gs>
+            <a:gs pos="100000">
+              <a:schemeClr val="phClr">
+                <a:shade val="63000"/>
+                <a:satMod val="120000"/>
+              </a:schemeClr>
+            </a:gs>
+          </a:gsLst>
+          <a:lin ang="5400000" scaled="0"/>
+        </a:gradFill>
+      </a:bgFillStyleLst>
+    </a:fmtScheme>
+  </a:themeElements>
+  <a:objectDefaults>
+    <a:lnDef>
+      <a:spPr/>
+      <a:bodyPr/>
+      <a:lstStyle/>
+      <a:style>
+        <a:lnRef idx="2">
+          <a:schemeClr val="accent1"/>
+        </a:lnRef>
+        <a:fillRef idx="0">
+          <a:schemeClr val="accent1"/>
+        </a:fillRef>
+        <a:effectRef idx="1">
+          <a:schemeClr val="accent1"/>
+        </a:effectRef>
+        <a:fontRef idx="minor">
+          <a:schemeClr val="tx1"/>
+        </a:fontRef>
+      </a:style>
+    </a:lnDef>
+  </a:objectDefaults>
+  <a:extraClrSchemeLst/>
+  <a:extLst>
+    <a:ext uri="{05A4C25C-085E-4340-85A3-A5531E510DB2}">
+      <thm15:themeFamily xmlns:thm15="http://schemas.microsoft.com/office/thememl/2012/main" name="Office Theme" id="{2E142A2C-CD16-42D6-873A-C26D2A0506FA}" vid="{1BDDFF52-6CD6-40A5-AB3C-68EB2F1E4D0A}"/>
+    </a:ext>
+  </a:extLst>
+</a:theme>
 </file>
</xml_diff>

<commit_message>
Chốt Tuần 5: cập nhật báo cáo PowerPoint (panel Tuần 5, 65,8% toàn dự án)
</commit_message>
<xml_diff>
--- a/docs/teaching-notes/bao-cao-tuan/Bao_cao_tien_do_Tuan_LACCO.pptx
+++ b/docs/teaching-notes/bao-cao-tuan/Bao_cao_tien_do_Tuan_LACCO.pptx
@@ -757,7 +757,7 @@
                 <a:ea typeface="Arial" pitchFamily="34" charset="-122"/>
                 <a:cs typeface="Arial" pitchFamily="34" charset="-120"/>
               </a:rPr>
-              <a:t>Giai đoạn 1 (WebApp MVP · 8 tuần)  ·  Cập nhật Tuần 4 — 07/09/2026</a:t>
+              <a:t>Giai đoạn 1 (WebApp MVP · 8 tuần)  ·  Cập nhật Tuần 5 — 09/09/2026</a:t>
             </a:r>
             <a:endParaRPr lang="en-US" sz="1200" dirty="0"/>
           </a:p>
@@ -825,7 +825,7 @@
                 <a:ea typeface="Arial" pitchFamily="34" charset="-122"/>
                 <a:cs typeface="Arial" pitchFamily="34" charset="-120"/>
               </a:rPr>
-              <a:t>55,3%</a:t>
+              <a:t>65,8%</a:t>
             </a:r>
             <a:endParaRPr lang="en-US" sz="2700" dirty="0"/>
           </a:p>
@@ -864,7 +864,7 @@
                 <a:ea typeface="Arial" pitchFamily="34" charset="-122"/>
                 <a:cs typeface="Arial" pitchFamily="34" charset="-120"/>
               </a:rPr>
-              <a:t>Toàn dự án · 21/38 bước</a:t>
+              <a:t>Toàn dự án · 25/38 bước</a:t>
             </a:r>
             <a:endParaRPr lang="en-US" sz="900" dirty="0"/>
           </a:p>
@@ -971,7 +971,7 @@
                 <a:ea typeface="Arial" pitchFamily="34" charset="-122"/>
                 <a:cs typeface="Arial" pitchFamily="34" charset="-120"/>
               </a:rPr>
-              <a:t>Tuần 4 · 4/4 bước</a:t>
+              <a:t>Tuần 5 · 4/4 bước</a:t>
             </a:r>
             <a:endParaRPr lang="en-US" sz="900" dirty="0"/>
           </a:p>
@@ -2589,7 +2589,7 @@
                 <a:ea typeface="Arial" pitchFamily="34" charset="-122"/>
                 <a:cs typeface="Arial" pitchFamily="34" charset="-120"/>
               </a:rPr>
-              <a:t>TUẦN 4 — CHI TIẾT 4 BƯỚC</a:t>
+              <a:t>TUẦN 5 — CHI TIẾT 4 BƯỚC</a:t>
             </a:r>
             <a:endParaRPr lang="en-US" sz="1300" dirty="0"/>
           </a:p>
@@ -2694,7 +2694,7 @@
                 <a:ea typeface="Arial" pitchFamily="34" charset="-122"/>
                 <a:cs typeface="Arial" pitchFamily="34" charset="-120"/>
               </a:rPr>
-              <a:t>4.1  Chạy song song 2 module báo cáo (report-builder-agent x2)</a:t>
+              <a:t>5.1  Chạy song song 4 module báo cáo (2 đợt x 2 report-builder-agent)</a:t>
             </a:r>
             <a:endParaRPr lang="en-US" sz="1100" dirty="0"/>
           </a:p>
@@ -2799,7 +2799,7 @@
                 <a:ea typeface="Arial" pitchFamily="34" charset="-122"/>
                 <a:cs typeface="Arial" pitchFamily="34" charset="-120"/>
               </a:rPr>
-              <a:t>4.2  Audit cache an toàn multi-user (qa-reviewer-agent)</a:t>
+              <a:t>5.2  Đồng bộ tài liệu kiến trúc SDD.md/README (doc-writer-agent)</a:t>
             </a:r>
             <a:endParaRPr lang="en-US" sz="1100" dirty="0"/>
           </a:p>
@@ -2904,7 +2904,7 @@
                 <a:ea typeface="Arial" pitchFamily="34" charset="-122"/>
                 <a:cs typeface="Arial" pitchFamily="34" charset="-120"/>
               </a:rPr>
-              <a:t>4.3  Đối chiếu KPI &amp; bổ sung theo Phụ lục B (SDD gốc)</a:t>
+              <a:t>5.3  Checkpoint giữa dự án: đối chiếu tiến độ thực tế vs kế hoạch</a:t>
             </a:r>
             <a:endParaRPr lang="en-US" sz="1100" dirty="0"/>
           </a:p>
@@ -3009,7 +3009,7 @@
                 <a:ea typeface="Arial" pitchFamily="34" charset="-122"/>
                 <a:cs typeface="Arial" pitchFamily="34" charset="-120"/>
               </a:rPr>
-              <a:t>4.4  Review &amp; nhật ký Tuần 4</a:t>
+              <a:t>5.4  Review &amp; nhật ký Tuần 5</a:t>
             </a:r>
             <a:endParaRPr lang="en-US" sz="1100" dirty="0"/>
           </a:p>
@@ -3130,7 +3130,7 @@
                 <a:ea typeface="Arial" pitchFamily="34" charset="-122"/>
                 <a:cs typeface="Arial" pitchFamily="34" charset="-120"/>
               </a:rPr>
-              <a:t>Bắt đầu bước 5.1 — 4 module báo cáo còn lại: Đơn hàng, Pricing, Chi phí, Công nợ (mô tả gốc bước 5.1 trong tracker ghi nhầm thêm "Dòng tiền" — đã chốt dời Giai đoạn 2 từ bước 1.3, đã sửa lại tracker)</a:t>
+              <a:t>Tất cả 5/5 nhóm báo cáo Giai đoạn 1 đã hoạt động (Kinh doanh, Khách hàng, Pricing, Chi phí, Công nợ) — đạt tiêu chí nghiệm thu MVP #1 về tính năng; CI test coverage cho src/services/ vẫn đang là 0%</a:t>
             </a:r>
             <a:endParaRPr lang="en-US" sz="1100" dirty="0"/>
           </a:p>
@@ -3154,7 +3154,7 @@
                 <a:ea typeface="Arial" pitchFamily="34" charset="-122"/>
                 <a:cs typeface="Arial" pitchFamily="34" charset="-120"/>
               </a:rPr>
-              <a:t>Mở rộng &gt;2 subagent chạy song song ở Tuần 5 — cần xác định giới hạn hợp lý trước khi giao việc</a:t>
+              <a:t>Khuyến nghị từ checkpoint bước 5.3: ưu tiên xử lý bảo mật (MySQL least-privilege user, _DEV_FALLBACK_COOKIE_KEY) TRƯỚC bước 7.2 (Deploy Windows Server); bổ sung test coverage cho report_*.py/admin_actions.py trước/trong bước 7.1 (Test suite cuối)</a:t>
             </a:r>
             <a:endParaRPr lang="en-US" sz="1100" dirty="0"/>
           </a:p>
@@ -3178,7 +3178,7 @@
                 <a:ea typeface="Arial" pitchFamily="34" charset="-122"/>
                 <a:cs typeface="Arial" pitchFamily="34" charset="-120"/>
               </a:rPr>
-              <a:t>Tồn đọng: MySQL least-privilege user thay root (từ Tuần 1), _DEV_FALLBACK_COOKIE_KEY cần raise lỗi trước production, admin_actions.py 0% coverage</a:t>
+              <a:t>Tiến độ theo lịch (không phải nội dung) trễ ổn định ~2 tuần kể từ Tuần 1, không có dấu hiệu trễ thêm — không cần rush hay cắt phạm vi (tracker coi ngày là mốc linh hoạt, không phải deadline cứng)</a:t>
             </a:r>
             <a:endParaRPr lang="en-US" sz="1100" dirty="0"/>
           </a:p>
@@ -3202,7 +3202,7 @@
                 <a:ea typeface="Arial" pitchFamily="34" charset="-122"/>
                 <a:cs typeface="Arial" pitchFamily="34" charset="-120"/>
               </a:rPr>
-              <a:t>Rủi ro overlap KH/NV (nêu ở Tuần 3) đã xử lý ở bước 4.1 — không còn là rủi ro mở</a:t>
+              <a:t>Tồn đọng: một số mục erd-tuan-02.md/SDD.md còn mở (không chặn tiến độ, xử lý khi thuận tiện); tuỳ chọn (không bắt buộc) cập nhật lại ngày dự kiến Tuần 6-8 trong tracker cho khớp độ trễ quan sát được</a:t>
             </a:r>
             <a:endParaRPr lang="en-US" sz="1100" dirty="0"/>
           </a:p>
@@ -3353,6 +3353,74 @@
         <p:spPr>
           <a:xfrm>
             <a:off x="4814970" y="3182112"/>
+            <a:ext cx="1133856" cy="237744"/>
+          </a:xfrm>
+          <a:prstGeom prst="rect">
+            <a:avLst/>
+          </a:prstGeom>
+          <a:noFill/>
+          <a:ln/>
+        </p:spPr>
+        <p:txBody>
+          <a:bodyPr wrap="square" lIns="0" tIns="0" rIns="0" bIns="0" rtlCol="0" anchor="ctr"/>
+          <a:lstStyle/>
+          <a:p>
+            <a:pPr marL="0" indent="0" algn="ctr">
+              <a:buNone/>
+            </a:pPr>
+            <a:r>
+              <a:rPr lang="en-US" sz="850" b="1" dirty="0">
+                <a:solidFill>
+                  <a:srgbClr val="FFFFFF"/>
+                </a:solidFill>
+                <a:latin typeface="Arial" pitchFamily="34" charset="0"/>
+                <a:ea typeface="Arial" pitchFamily="34" charset="-122"/>
+                <a:cs typeface="Arial" pitchFamily="34" charset="-120"/>
+              </a:rPr>
+              <a:t>Hoàn thành · 100%</a:t>
+            </a:r>
+            <a:endParaRPr lang="en-US" sz="850" dirty="0"/>
+          </a:p>
+        </p:txBody>
+      </p:sp>
+      <p:sp>
+        <p:nvSpPr>
+          <p:cNvPr id="5017" name="Shape 15 (Tuan5)"/>
+          <p:cNvSpPr/>
+          <p:nvPr/>
+        </p:nvSpPr>
+        <p:spPr>
+          <a:xfrm>
+            <a:off x="6258416" y="3182112"/>
+            <a:ext cx="1133856" cy="237744"/>
+          </a:xfrm>
+          <a:prstGeom prst="roundRect">
+            <a:avLst>
+              <a:gd name="adj" fmla="val 23077"/>
+            </a:avLst>
+          </a:prstGeom>
+          <a:solidFill>
+            <a:srgbClr val="2E8B57"/>
+          </a:solidFill>
+          <a:ln/>
+        </p:spPr>
+        <p:txBody>
+          <a:bodyPr/>
+          <a:lstStyle/>
+          <a:p>
+            <a:endParaRPr lang="en-US"/>
+          </a:p>
+        </p:txBody>
+      </p:sp>
+      <p:sp>
+        <p:nvSpPr>
+          <p:cNvPr id="5019" name="Text 16 (Tuan5)"/>
+          <p:cNvSpPr/>
+          <p:nvPr/>
+        </p:nvSpPr>
+        <p:spPr>
+          <a:xfrm>
+            <a:off x="6258416" y="3182112"/>
             <a:ext cx="1133856" cy="237744"/>
           </a:xfrm>
           <a:prstGeom prst="rect">

</xml_diff>